<commit_message>
fix: Keynote compatibility - eliminate zero-extent shapes
Keynote rejects the file with 'file format is invalid' when it contains
zero-extent shapes (cy=0 / cx=0). Separator lines were drawn as connectors,
producing 18 such shapes per deck. They are now thin rectangles, which also
removes p:cxnSp entirely. Also removed one empty text run.

Added deckkit.audit_pptx() so every future build is checked for:
zero-extent shapes, connectors, empty runs, rPr child ordering.

Fallback formats added for maximum compatibility:
- pdf/PPT-01.pdf, pdf/PPT-02.pdf  (18 pages each, Keynote opens natively)
- download/PPT-0x-slides-png/     (18 PNGs per deck)

Co-authored-by: arena-agent <297053741+arena-agent@users.noreply.github.com>
</commit_message>
<xml_diff>
--- a/ppt/PPT-01-Roll-Material-MES-System-Proposal.pptx
+++ b/ppt/PPT-01-Roll-Material-MES-System-Proposal.pptx
@@ -4930,41 +4930,50 @@
           </a:p>
         </p:txBody>
       </p:sp>
-      <p:cxnSp>
-        <p:nvCxnSpPr>
-          <p:cNvPr id="7" name="Connector 6"/>
-          <p:cNvCxnSpPr/>
-          <p:nvPr/>
-        </p:nvCxnSpPr>
-        <p:spPr>
-          <a:xfrm>
-            <a:off x="566928" y="3529584"/>
-            <a:ext cx="5120640" cy="0"/>
-          </a:xfrm>
-          <a:prstGeom prst="line">
-            <a:avLst/>
-          </a:prstGeom>
-          <a:ln w="25400">
-            <a:solidFill>
-              <a:srgbClr val="2F6BE4"/>
-            </a:solidFill>
+      <p:sp>
+        <p:nvSpPr>
+          <p:cNvPr id="7" name="Rectangle 6"/>
+          <p:cNvSpPr/>
+          <p:nvPr/>
+        </p:nvSpPr>
+        <p:spPr>
+          <a:xfrm>
+            <a:off x="566928" y="3516884"/>
+            <a:ext cx="5120640" cy="25400"/>
+          </a:xfrm>
+          <a:prstGeom prst="rect">
+            <a:avLst/>
+          </a:prstGeom>
+          <a:solidFill>
+            <a:srgbClr val="2F6BE4"/>
+          </a:solidFill>
+          <a:ln>
+            <a:noFill/>
           </a:ln>
+          <a:effectLst/>
         </p:spPr>
         <p:style>
-          <a:lnRef idx="2">
+          <a:lnRef idx="1">
             <a:schemeClr val="accent1"/>
           </a:lnRef>
-          <a:fillRef idx="0">
+          <a:fillRef idx="3">
             <a:schemeClr val="accent1"/>
           </a:fillRef>
-          <a:effectRef idx="1">
+          <a:effectRef idx="2">
             <a:schemeClr val="accent1"/>
           </a:effectRef>
           <a:fontRef idx="minor">
-            <a:schemeClr val="tx1"/>
+            <a:schemeClr val="lt1"/>
           </a:fontRef>
         </p:style>
-      </p:cxnSp>
+        <p:txBody>
+          <a:bodyPr rtlCol="0" anchor="ctr"/>
+          <a:lstStyle/>
+          <a:p>
+            <a:pPr algn="ctr"/>
+          </a:p>
+        </p:txBody>
+      </p:sp>
       <p:sp>
         <p:nvSpPr>
           <p:cNvPr id="8" name="TextBox 7"/>
@@ -5697,41 +5706,50 @@
           </a:p>
         </p:txBody>
       </p:sp>
-      <p:cxnSp>
-        <p:nvCxnSpPr>
-          <p:cNvPr id="6" name="Connector 5"/>
-          <p:cNvCxnSpPr/>
-          <p:nvPr/>
-        </p:nvCxnSpPr>
-        <p:spPr>
-          <a:xfrm>
-            <a:off x="566928" y="1591056"/>
-            <a:ext cx="11058113" cy="0"/>
-          </a:xfrm>
-          <a:prstGeom prst="line">
-            <a:avLst/>
-          </a:prstGeom>
-          <a:ln w="12700">
-            <a:solidFill>
-              <a:srgbClr val="D9E0EA"/>
-            </a:solidFill>
+      <p:sp>
+        <p:nvSpPr>
+          <p:cNvPr id="6" name="Rectangle 5"/>
+          <p:cNvSpPr/>
+          <p:nvPr/>
+        </p:nvSpPr>
+        <p:spPr>
+          <a:xfrm>
+            <a:off x="566928" y="1584706"/>
+            <a:ext cx="11058113" cy="12700"/>
+          </a:xfrm>
+          <a:prstGeom prst="rect">
+            <a:avLst/>
+          </a:prstGeom>
+          <a:solidFill>
+            <a:srgbClr val="D9E0EA"/>
+          </a:solidFill>
+          <a:ln>
+            <a:noFill/>
           </a:ln>
+          <a:effectLst/>
         </p:spPr>
         <p:style>
-          <a:lnRef idx="2">
+          <a:lnRef idx="1">
             <a:schemeClr val="accent1"/>
           </a:lnRef>
-          <a:fillRef idx="0">
+          <a:fillRef idx="3">
             <a:schemeClr val="accent1"/>
           </a:fillRef>
-          <a:effectRef idx="1">
+          <a:effectRef idx="2">
             <a:schemeClr val="accent1"/>
           </a:effectRef>
           <a:fontRef idx="minor">
-            <a:schemeClr val="tx1"/>
+            <a:schemeClr val="lt1"/>
           </a:fontRef>
         </p:style>
-      </p:cxnSp>
+        <p:txBody>
+          <a:bodyPr rtlCol="0" anchor="ctr"/>
+          <a:lstStyle/>
+          <a:p>
+            <a:pPr algn="ctr"/>
+          </a:p>
+        </p:txBody>
+      </p:sp>
       <p:sp>
         <p:nvSpPr>
           <p:cNvPr id="7" name="TextBox 6"/>
@@ -6908,41 +6926,50 @@
           </a:p>
         </p:txBody>
       </p:sp>
-      <p:cxnSp>
-        <p:nvCxnSpPr>
-          <p:cNvPr id="6" name="Connector 5"/>
-          <p:cNvCxnSpPr/>
-          <p:nvPr/>
-        </p:nvCxnSpPr>
-        <p:spPr>
-          <a:xfrm>
-            <a:off x="566928" y="1591056"/>
-            <a:ext cx="11058113" cy="0"/>
-          </a:xfrm>
-          <a:prstGeom prst="line">
-            <a:avLst/>
-          </a:prstGeom>
-          <a:ln w="12700">
-            <a:solidFill>
-              <a:srgbClr val="D9E0EA"/>
-            </a:solidFill>
+      <p:sp>
+        <p:nvSpPr>
+          <p:cNvPr id="6" name="Rectangle 5"/>
+          <p:cNvSpPr/>
+          <p:nvPr/>
+        </p:nvSpPr>
+        <p:spPr>
+          <a:xfrm>
+            <a:off x="566928" y="1584706"/>
+            <a:ext cx="11058113" cy="12700"/>
+          </a:xfrm>
+          <a:prstGeom prst="rect">
+            <a:avLst/>
+          </a:prstGeom>
+          <a:solidFill>
+            <a:srgbClr val="D9E0EA"/>
+          </a:solidFill>
+          <a:ln>
+            <a:noFill/>
           </a:ln>
+          <a:effectLst/>
         </p:spPr>
         <p:style>
-          <a:lnRef idx="2">
+          <a:lnRef idx="1">
             <a:schemeClr val="accent1"/>
           </a:lnRef>
-          <a:fillRef idx="0">
+          <a:fillRef idx="3">
             <a:schemeClr val="accent1"/>
           </a:fillRef>
-          <a:effectRef idx="1">
+          <a:effectRef idx="2">
             <a:schemeClr val="accent1"/>
           </a:effectRef>
           <a:fontRef idx="minor">
-            <a:schemeClr val="tx1"/>
+            <a:schemeClr val="lt1"/>
           </a:fontRef>
         </p:style>
-      </p:cxnSp>
+        <p:txBody>
+          <a:bodyPr rtlCol="0" anchor="ctr"/>
+          <a:lstStyle/>
+          <a:p>
+            <a:pPr algn="ctr"/>
+          </a:p>
+        </p:txBody>
+      </p:sp>
       <p:sp>
         <p:nvSpPr>
           <p:cNvPr id="7" name="TextBox 6"/>
@@ -8445,41 +8472,50 @@
           </a:p>
         </p:txBody>
       </p:sp>
-      <p:cxnSp>
-        <p:nvCxnSpPr>
-          <p:cNvPr id="6" name="Connector 5"/>
-          <p:cNvCxnSpPr/>
-          <p:nvPr/>
-        </p:nvCxnSpPr>
-        <p:spPr>
-          <a:xfrm>
-            <a:off x="566928" y="1591056"/>
-            <a:ext cx="11058113" cy="0"/>
-          </a:xfrm>
-          <a:prstGeom prst="line">
-            <a:avLst/>
-          </a:prstGeom>
-          <a:ln w="12700">
-            <a:solidFill>
-              <a:srgbClr val="D9E0EA"/>
-            </a:solidFill>
+      <p:sp>
+        <p:nvSpPr>
+          <p:cNvPr id="6" name="Rectangle 5"/>
+          <p:cNvSpPr/>
+          <p:nvPr/>
+        </p:nvSpPr>
+        <p:spPr>
+          <a:xfrm>
+            <a:off x="566928" y="1584706"/>
+            <a:ext cx="11058113" cy="12700"/>
+          </a:xfrm>
+          <a:prstGeom prst="rect">
+            <a:avLst/>
+          </a:prstGeom>
+          <a:solidFill>
+            <a:srgbClr val="D9E0EA"/>
+          </a:solidFill>
+          <a:ln>
+            <a:noFill/>
           </a:ln>
+          <a:effectLst/>
         </p:spPr>
         <p:style>
-          <a:lnRef idx="2">
+          <a:lnRef idx="1">
             <a:schemeClr val="accent1"/>
           </a:lnRef>
-          <a:fillRef idx="0">
+          <a:fillRef idx="3">
             <a:schemeClr val="accent1"/>
           </a:fillRef>
-          <a:effectRef idx="1">
+          <a:effectRef idx="2">
             <a:schemeClr val="accent1"/>
           </a:effectRef>
           <a:fontRef idx="minor">
-            <a:schemeClr val="tx1"/>
+            <a:schemeClr val="lt1"/>
           </a:fontRef>
         </p:style>
-      </p:cxnSp>
+        <p:txBody>
+          <a:bodyPr rtlCol="0" anchor="ctr"/>
+          <a:lstStyle/>
+          <a:p>
+            <a:pPr algn="ctr"/>
+          </a:p>
+        </p:txBody>
+      </p:sp>
       <p:sp>
         <p:nvSpPr>
           <p:cNvPr id="7" name="TextBox 6"/>
@@ -9488,41 +9524,50 @@
           </a:p>
         </p:txBody>
       </p:sp>
-      <p:cxnSp>
-        <p:nvCxnSpPr>
-          <p:cNvPr id="6" name="Connector 5"/>
-          <p:cNvCxnSpPr/>
-          <p:nvPr/>
-        </p:nvCxnSpPr>
-        <p:spPr>
-          <a:xfrm>
-            <a:off x="566928" y="1591056"/>
-            <a:ext cx="11058113" cy="0"/>
-          </a:xfrm>
-          <a:prstGeom prst="line">
-            <a:avLst/>
-          </a:prstGeom>
-          <a:ln w="12700">
-            <a:solidFill>
-              <a:srgbClr val="D9E0EA"/>
-            </a:solidFill>
+      <p:sp>
+        <p:nvSpPr>
+          <p:cNvPr id="6" name="Rectangle 5"/>
+          <p:cNvSpPr/>
+          <p:nvPr/>
+        </p:nvSpPr>
+        <p:spPr>
+          <a:xfrm>
+            <a:off x="566928" y="1584706"/>
+            <a:ext cx="11058113" cy="12700"/>
+          </a:xfrm>
+          <a:prstGeom prst="rect">
+            <a:avLst/>
+          </a:prstGeom>
+          <a:solidFill>
+            <a:srgbClr val="D9E0EA"/>
+          </a:solidFill>
+          <a:ln>
+            <a:noFill/>
           </a:ln>
+          <a:effectLst/>
         </p:spPr>
         <p:style>
-          <a:lnRef idx="2">
+          <a:lnRef idx="1">
             <a:schemeClr val="accent1"/>
           </a:lnRef>
-          <a:fillRef idx="0">
+          <a:fillRef idx="3">
             <a:schemeClr val="accent1"/>
           </a:fillRef>
-          <a:effectRef idx="1">
+          <a:effectRef idx="2">
             <a:schemeClr val="accent1"/>
           </a:effectRef>
           <a:fontRef idx="minor">
-            <a:schemeClr val="tx1"/>
+            <a:schemeClr val="lt1"/>
           </a:fontRef>
         </p:style>
-      </p:cxnSp>
+        <p:txBody>
+          <a:bodyPr rtlCol="0" anchor="ctr"/>
+          <a:lstStyle/>
+          <a:p>
+            <a:pPr algn="ctr"/>
+          </a:p>
+        </p:txBody>
+      </p:sp>
       <p:sp>
         <p:nvSpPr>
           <p:cNvPr id="7" name="TextBox 6"/>
@@ -11328,41 +11373,50 @@
           </a:p>
         </p:txBody>
       </p:sp>
-      <p:cxnSp>
-        <p:nvCxnSpPr>
-          <p:cNvPr id="6" name="Connector 5"/>
-          <p:cNvCxnSpPr/>
-          <p:nvPr/>
-        </p:nvCxnSpPr>
-        <p:spPr>
-          <a:xfrm>
-            <a:off x="566928" y="1591056"/>
-            <a:ext cx="11058113" cy="0"/>
-          </a:xfrm>
-          <a:prstGeom prst="line">
-            <a:avLst/>
-          </a:prstGeom>
-          <a:ln w="12700">
-            <a:solidFill>
-              <a:srgbClr val="D9E0EA"/>
-            </a:solidFill>
+      <p:sp>
+        <p:nvSpPr>
+          <p:cNvPr id="6" name="Rectangle 5"/>
+          <p:cNvSpPr/>
+          <p:nvPr/>
+        </p:nvSpPr>
+        <p:spPr>
+          <a:xfrm>
+            <a:off x="566928" y="1584706"/>
+            <a:ext cx="11058113" cy="12700"/>
+          </a:xfrm>
+          <a:prstGeom prst="rect">
+            <a:avLst/>
+          </a:prstGeom>
+          <a:solidFill>
+            <a:srgbClr val="D9E0EA"/>
+          </a:solidFill>
+          <a:ln>
+            <a:noFill/>
           </a:ln>
+          <a:effectLst/>
         </p:spPr>
         <p:style>
-          <a:lnRef idx="2">
+          <a:lnRef idx="1">
             <a:schemeClr val="accent1"/>
           </a:lnRef>
-          <a:fillRef idx="0">
+          <a:fillRef idx="3">
             <a:schemeClr val="accent1"/>
           </a:fillRef>
-          <a:effectRef idx="1">
+          <a:effectRef idx="2">
             <a:schemeClr val="accent1"/>
           </a:effectRef>
           <a:fontRef idx="minor">
-            <a:schemeClr val="tx1"/>
+            <a:schemeClr val="lt1"/>
           </a:fontRef>
         </p:style>
-      </p:cxnSp>
+        <p:txBody>
+          <a:bodyPr rtlCol="0" anchor="ctr"/>
+          <a:lstStyle/>
+          <a:p>
+            <a:pPr algn="ctr"/>
+          </a:p>
+        </p:txBody>
+      </p:sp>
       <p:sp>
         <p:nvSpPr>
           <p:cNvPr id="7" name="TextBox 6"/>
@@ -12803,41 +12857,50 @@
           </a:p>
         </p:txBody>
       </p:sp>
-      <p:cxnSp>
-        <p:nvCxnSpPr>
-          <p:cNvPr id="6" name="Connector 5"/>
-          <p:cNvCxnSpPr/>
-          <p:nvPr/>
-        </p:nvCxnSpPr>
-        <p:spPr>
-          <a:xfrm>
-            <a:off x="566928" y="1591056"/>
-            <a:ext cx="11058113" cy="0"/>
-          </a:xfrm>
-          <a:prstGeom prst="line">
-            <a:avLst/>
-          </a:prstGeom>
-          <a:ln w="12700">
-            <a:solidFill>
-              <a:srgbClr val="D9E0EA"/>
-            </a:solidFill>
+      <p:sp>
+        <p:nvSpPr>
+          <p:cNvPr id="6" name="Rectangle 5"/>
+          <p:cNvSpPr/>
+          <p:nvPr/>
+        </p:nvSpPr>
+        <p:spPr>
+          <a:xfrm>
+            <a:off x="566928" y="1584706"/>
+            <a:ext cx="11058113" cy="12700"/>
+          </a:xfrm>
+          <a:prstGeom prst="rect">
+            <a:avLst/>
+          </a:prstGeom>
+          <a:solidFill>
+            <a:srgbClr val="D9E0EA"/>
+          </a:solidFill>
+          <a:ln>
+            <a:noFill/>
           </a:ln>
+          <a:effectLst/>
         </p:spPr>
         <p:style>
-          <a:lnRef idx="2">
+          <a:lnRef idx="1">
             <a:schemeClr val="accent1"/>
           </a:lnRef>
-          <a:fillRef idx="0">
+          <a:fillRef idx="3">
             <a:schemeClr val="accent1"/>
           </a:fillRef>
-          <a:effectRef idx="1">
+          <a:effectRef idx="2">
             <a:schemeClr val="accent1"/>
           </a:effectRef>
           <a:fontRef idx="minor">
-            <a:schemeClr val="tx1"/>
+            <a:schemeClr val="lt1"/>
           </a:fontRef>
         </p:style>
-      </p:cxnSp>
+        <p:txBody>
+          <a:bodyPr rtlCol="0" anchor="ctr"/>
+          <a:lstStyle/>
+          <a:p>
+            <a:pPr algn="ctr"/>
+          </a:p>
+        </p:txBody>
+      </p:sp>
       <p:sp>
         <p:nvSpPr>
           <p:cNvPr id="7" name="TextBox 6"/>
@@ -14109,41 +14172,50 @@
           </a:p>
         </p:txBody>
       </p:sp>
-      <p:cxnSp>
-        <p:nvCxnSpPr>
-          <p:cNvPr id="6" name="Connector 5"/>
-          <p:cNvCxnSpPr/>
-          <p:nvPr/>
-        </p:nvCxnSpPr>
-        <p:spPr>
-          <a:xfrm>
-            <a:off x="566928" y="1591056"/>
-            <a:ext cx="11058113" cy="0"/>
-          </a:xfrm>
-          <a:prstGeom prst="line">
-            <a:avLst/>
-          </a:prstGeom>
-          <a:ln w="12700">
-            <a:solidFill>
-              <a:srgbClr val="D9E0EA"/>
-            </a:solidFill>
+      <p:sp>
+        <p:nvSpPr>
+          <p:cNvPr id="6" name="Rectangle 5"/>
+          <p:cNvSpPr/>
+          <p:nvPr/>
+        </p:nvSpPr>
+        <p:spPr>
+          <a:xfrm>
+            <a:off x="566928" y="1584706"/>
+            <a:ext cx="11058113" cy="12700"/>
+          </a:xfrm>
+          <a:prstGeom prst="rect">
+            <a:avLst/>
+          </a:prstGeom>
+          <a:solidFill>
+            <a:srgbClr val="D9E0EA"/>
+          </a:solidFill>
+          <a:ln>
+            <a:noFill/>
           </a:ln>
+          <a:effectLst/>
         </p:spPr>
         <p:style>
-          <a:lnRef idx="2">
+          <a:lnRef idx="1">
             <a:schemeClr val="accent1"/>
           </a:lnRef>
-          <a:fillRef idx="0">
+          <a:fillRef idx="3">
             <a:schemeClr val="accent1"/>
           </a:fillRef>
-          <a:effectRef idx="1">
+          <a:effectRef idx="2">
             <a:schemeClr val="accent1"/>
           </a:effectRef>
           <a:fontRef idx="minor">
-            <a:schemeClr val="tx1"/>
+            <a:schemeClr val="lt1"/>
           </a:fontRef>
         </p:style>
-      </p:cxnSp>
+        <p:txBody>
+          <a:bodyPr rtlCol="0" anchor="ctr"/>
+          <a:lstStyle/>
+          <a:p>
+            <a:pPr algn="ctr"/>
+          </a:p>
+        </p:txBody>
+      </p:sp>
       <p:sp>
         <p:nvSpPr>
           <p:cNvPr id="7" name="TextBox 6"/>
@@ -15380,41 +15452,50 @@
           </a:p>
         </p:txBody>
       </p:sp>
-      <p:cxnSp>
-        <p:nvCxnSpPr>
-          <p:cNvPr id="6" name="Connector 5"/>
-          <p:cNvCxnSpPr/>
-          <p:nvPr/>
-        </p:nvCxnSpPr>
-        <p:spPr>
-          <a:xfrm>
-            <a:off x="566928" y="1591056"/>
-            <a:ext cx="11058113" cy="0"/>
-          </a:xfrm>
-          <a:prstGeom prst="line">
-            <a:avLst/>
-          </a:prstGeom>
-          <a:ln w="12700">
-            <a:solidFill>
-              <a:srgbClr val="D9E0EA"/>
-            </a:solidFill>
+      <p:sp>
+        <p:nvSpPr>
+          <p:cNvPr id="6" name="Rectangle 5"/>
+          <p:cNvSpPr/>
+          <p:nvPr/>
+        </p:nvSpPr>
+        <p:spPr>
+          <a:xfrm>
+            <a:off x="566928" y="1584706"/>
+            <a:ext cx="11058113" cy="12700"/>
+          </a:xfrm>
+          <a:prstGeom prst="rect">
+            <a:avLst/>
+          </a:prstGeom>
+          <a:solidFill>
+            <a:srgbClr val="D9E0EA"/>
+          </a:solidFill>
+          <a:ln>
+            <a:noFill/>
           </a:ln>
+          <a:effectLst/>
         </p:spPr>
         <p:style>
-          <a:lnRef idx="2">
+          <a:lnRef idx="1">
             <a:schemeClr val="accent1"/>
           </a:lnRef>
-          <a:fillRef idx="0">
+          <a:fillRef idx="3">
             <a:schemeClr val="accent1"/>
           </a:fillRef>
-          <a:effectRef idx="1">
+          <a:effectRef idx="2">
             <a:schemeClr val="accent1"/>
           </a:effectRef>
           <a:fontRef idx="minor">
-            <a:schemeClr val="tx1"/>
+            <a:schemeClr val="lt1"/>
           </a:fontRef>
         </p:style>
-      </p:cxnSp>
+        <p:txBody>
+          <a:bodyPr rtlCol="0" anchor="ctr"/>
+          <a:lstStyle/>
+          <a:p>
+            <a:pPr algn="ctr"/>
+          </a:p>
+        </p:txBody>
+      </p:sp>
       <p:sp>
         <p:nvSpPr>
           <p:cNvPr id="7" name="TextBox 6"/>
@@ -16853,41 +16934,50 @@
           </a:p>
         </p:txBody>
       </p:sp>
-      <p:cxnSp>
-        <p:nvCxnSpPr>
-          <p:cNvPr id="6" name="Connector 5"/>
-          <p:cNvCxnSpPr/>
-          <p:nvPr/>
-        </p:nvCxnSpPr>
-        <p:spPr>
-          <a:xfrm>
-            <a:off x="566928" y="1591056"/>
-            <a:ext cx="11058113" cy="0"/>
-          </a:xfrm>
-          <a:prstGeom prst="line">
-            <a:avLst/>
-          </a:prstGeom>
-          <a:ln w="12700">
-            <a:solidFill>
-              <a:srgbClr val="D9E0EA"/>
-            </a:solidFill>
+      <p:sp>
+        <p:nvSpPr>
+          <p:cNvPr id="6" name="Rectangle 5"/>
+          <p:cNvSpPr/>
+          <p:nvPr/>
+        </p:nvSpPr>
+        <p:spPr>
+          <a:xfrm>
+            <a:off x="566928" y="1584706"/>
+            <a:ext cx="11058113" cy="12700"/>
+          </a:xfrm>
+          <a:prstGeom prst="rect">
+            <a:avLst/>
+          </a:prstGeom>
+          <a:solidFill>
+            <a:srgbClr val="D9E0EA"/>
+          </a:solidFill>
+          <a:ln>
+            <a:noFill/>
           </a:ln>
+          <a:effectLst/>
         </p:spPr>
         <p:style>
-          <a:lnRef idx="2">
+          <a:lnRef idx="1">
             <a:schemeClr val="accent1"/>
           </a:lnRef>
-          <a:fillRef idx="0">
+          <a:fillRef idx="3">
             <a:schemeClr val="accent1"/>
           </a:fillRef>
-          <a:effectRef idx="1">
+          <a:effectRef idx="2">
             <a:schemeClr val="accent1"/>
           </a:effectRef>
           <a:fontRef idx="minor">
-            <a:schemeClr val="tx1"/>
+            <a:schemeClr val="lt1"/>
           </a:fontRef>
         </p:style>
-      </p:cxnSp>
+        <p:txBody>
+          <a:bodyPr rtlCol="0" anchor="ctr"/>
+          <a:lstStyle/>
+          <a:p>
+            <a:pPr algn="ctr"/>
+          </a:p>
+        </p:txBody>
+      </p:sp>
       <p:sp>
         <p:nvSpPr>
           <p:cNvPr id="7" name="TextBox 6"/>
@@ -17799,41 +17889,50 @@
           </a:p>
         </p:txBody>
       </p:sp>
-      <p:cxnSp>
-        <p:nvCxnSpPr>
-          <p:cNvPr id="6" name="Connector 5"/>
-          <p:cNvCxnSpPr/>
-          <p:nvPr/>
-        </p:nvCxnSpPr>
-        <p:spPr>
-          <a:xfrm>
-            <a:off x="566928" y="1591056"/>
-            <a:ext cx="11058113" cy="0"/>
-          </a:xfrm>
-          <a:prstGeom prst="line">
-            <a:avLst/>
-          </a:prstGeom>
-          <a:ln w="12700">
-            <a:solidFill>
-              <a:srgbClr val="D9E0EA"/>
-            </a:solidFill>
+      <p:sp>
+        <p:nvSpPr>
+          <p:cNvPr id="6" name="Rectangle 5"/>
+          <p:cNvSpPr/>
+          <p:nvPr/>
+        </p:nvSpPr>
+        <p:spPr>
+          <a:xfrm>
+            <a:off x="566928" y="1584706"/>
+            <a:ext cx="11058113" cy="12700"/>
+          </a:xfrm>
+          <a:prstGeom prst="rect">
+            <a:avLst/>
+          </a:prstGeom>
+          <a:solidFill>
+            <a:srgbClr val="D9E0EA"/>
+          </a:solidFill>
+          <a:ln>
+            <a:noFill/>
           </a:ln>
+          <a:effectLst/>
         </p:spPr>
         <p:style>
-          <a:lnRef idx="2">
+          <a:lnRef idx="1">
             <a:schemeClr val="accent1"/>
           </a:lnRef>
-          <a:fillRef idx="0">
+          <a:fillRef idx="3">
             <a:schemeClr val="accent1"/>
           </a:fillRef>
-          <a:effectRef idx="1">
+          <a:effectRef idx="2">
             <a:schemeClr val="accent1"/>
           </a:effectRef>
           <a:fontRef idx="minor">
-            <a:schemeClr val="tx1"/>
+            <a:schemeClr val="lt1"/>
           </a:fontRef>
         </p:style>
-      </p:cxnSp>
+        <p:txBody>
+          <a:bodyPr rtlCol="0" anchor="ctr"/>
+          <a:lstStyle/>
+          <a:p>
+            <a:pPr algn="ctr"/>
+          </a:p>
+        </p:txBody>
+      </p:sp>
       <p:sp>
         <p:nvSpPr>
           <p:cNvPr id="7" name="TextBox 6"/>
@@ -18660,41 +18759,50 @@
           </a:p>
         </p:txBody>
       </p:sp>
-      <p:cxnSp>
-        <p:nvCxnSpPr>
-          <p:cNvPr id="6" name="Connector 5"/>
-          <p:cNvCxnSpPr/>
-          <p:nvPr/>
-        </p:nvCxnSpPr>
-        <p:spPr>
-          <a:xfrm>
-            <a:off x="566928" y="1591056"/>
-            <a:ext cx="11058113" cy="0"/>
-          </a:xfrm>
-          <a:prstGeom prst="line">
-            <a:avLst/>
-          </a:prstGeom>
-          <a:ln w="12700">
-            <a:solidFill>
-              <a:srgbClr val="D9E0EA"/>
-            </a:solidFill>
+      <p:sp>
+        <p:nvSpPr>
+          <p:cNvPr id="6" name="Rectangle 5"/>
+          <p:cNvSpPr/>
+          <p:nvPr/>
+        </p:nvSpPr>
+        <p:spPr>
+          <a:xfrm>
+            <a:off x="566928" y="1584706"/>
+            <a:ext cx="11058113" cy="12700"/>
+          </a:xfrm>
+          <a:prstGeom prst="rect">
+            <a:avLst/>
+          </a:prstGeom>
+          <a:solidFill>
+            <a:srgbClr val="D9E0EA"/>
+          </a:solidFill>
+          <a:ln>
+            <a:noFill/>
           </a:ln>
+          <a:effectLst/>
         </p:spPr>
         <p:style>
-          <a:lnRef idx="2">
+          <a:lnRef idx="1">
             <a:schemeClr val="accent1"/>
           </a:lnRef>
-          <a:fillRef idx="0">
+          <a:fillRef idx="3">
             <a:schemeClr val="accent1"/>
           </a:fillRef>
-          <a:effectRef idx="1">
+          <a:effectRef idx="2">
             <a:schemeClr val="accent1"/>
           </a:effectRef>
           <a:fontRef idx="minor">
-            <a:schemeClr val="tx1"/>
+            <a:schemeClr val="lt1"/>
           </a:fontRef>
         </p:style>
-      </p:cxnSp>
+        <p:txBody>
+          <a:bodyPr rtlCol="0" anchor="ctr"/>
+          <a:lstStyle/>
+          <a:p>
+            <a:pPr algn="ctr"/>
+          </a:p>
+        </p:txBody>
+      </p:sp>
       <p:sp>
         <p:nvSpPr>
           <p:cNvPr id="7" name="TextBox 6"/>
@@ -19818,41 +19926,50 @@
           </a:p>
         </p:txBody>
       </p:sp>
-      <p:cxnSp>
-        <p:nvCxnSpPr>
-          <p:cNvPr id="6" name="Connector 5"/>
-          <p:cNvCxnSpPr/>
-          <p:nvPr/>
-        </p:nvCxnSpPr>
-        <p:spPr>
-          <a:xfrm>
-            <a:off x="566928" y="1591056"/>
-            <a:ext cx="11058113" cy="0"/>
-          </a:xfrm>
-          <a:prstGeom prst="line">
-            <a:avLst/>
-          </a:prstGeom>
-          <a:ln w="12700">
-            <a:solidFill>
-              <a:srgbClr val="D9E0EA"/>
-            </a:solidFill>
+      <p:sp>
+        <p:nvSpPr>
+          <p:cNvPr id="6" name="Rectangle 5"/>
+          <p:cNvSpPr/>
+          <p:nvPr/>
+        </p:nvSpPr>
+        <p:spPr>
+          <a:xfrm>
+            <a:off x="566928" y="1584706"/>
+            <a:ext cx="11058113" cy="12700"/>
+          </a:xfrm>
+          <a:prstGeom prst="rect">
+            <a:avLst/>
+          </a:prstGeom>
+          <a:solidFill>
+            <a:srgbClr val="D9E0EA"/>
+          </a:solidFill>
+          <a:ln>
+            <a:noFill/>
           </a:ln>
+          <a:effectLst/>
         </p:spPr>
         <p:style>
-          <a:lnRef idx="2">
+          <a:lnRef idx="1">
             <a:schemeClr val="accent1"/>
           </a:lnRef>
-          <a:fillRef idx="0">
+          <a:fillRef idx="3">
             <a:schemeClr val="accent1"/>
           </a:fillRef>
-          <a:effectRef idx="1">
+          <a:effectRef idx="2">
             <a:schemeClr val="accent1"/>
           </a:effectRef>
           <a:fontRef idx="minor">
-            <a:schemeClr val="tx1"/>
+            <a:schemeClr val="lt1"/>
           </a:fontRef>
         </p:style>
-      </p:cxnSp>
+        <p:txBody>
+          <a:bodyPr rtlCol="0" anchor="ctr"/>
+          <a:lstStyle/>
+          <a:p>
+            <a:pPr algn="ctr"/>
+          </a:p>
+        </p:txBody>
+      </p:sp>
       <p:sp>
         <p:nvSpPr>
           <p:cNvPr id="7" name="TextBox 6"/>
@@ -20955,41 +21072,50 @@
           </a:p>
         </p:txBody>
       </p:sp>
-      <p:cxnSp>
-        <p:nvCxnSpPr>
-          <p:cNvPr id="6" name="Connector 5"/>
-          <p:cNvCxnSpPr/>
-          <p:nvPr/>
-        </p:nvCxnSpPr>
-        <p:spPr>
-          <a:xfrm>
-            <a:off x="566928" y="1591056"/>
-            <a:ext cx="11058113" cy="0"/>
-          </a:xfrm>
-          <a:prstGeom prst="line">
-            <a:avLst/>
-          </a:prstGeom>
-          <a:ln w="12700">
-            <a:solidFill>
-              <a:srgbClr val="D9E0EA"/>
-            </a:solidFill>
+      <p:sp>
+        <p:nvSpPr>
+          <p:cNvPr id="6" name="Rectangle 5"/>
+          <p:cNvSpPr/>
+          <p:nvPr/>
+        </p:nvSpPr>
+        <p:spPr>
+          <a:xfrm>
+            <a:off x="566928" y="1584706"/>
+            <a:ext cx="11058113" cy="12700"/>
+          </a:xfrm>
+          <a:prstGeom prst="rect">
+            <a:avLst/>
+          </a:prstGeom>
+          <a:solidFill>
+            <a:srgbClr val="D9E0EA"/>
+          </a:solidFill>
+          <a:ln>
+            <a:noFill/>
           </a:ln>
+          <a:effectLst/>
         </p:spPr>
         <p:style>
-          <a:lnRef idx="2">
+          <a:lnRef idx="1">
             <a:schemeClr val="accent1"/>
           </a:lnRef>
-          <a:fillRef idx="0">
+          <a:fillRef idx="3">
             <a:schemeClr val="accent1"/>
           </a:fillRef>
-          <a:effectRef idx="1">
+          <a:effectRef idx="2">
             <a:schemeClr val="accent1"/>
           </a:effectRef>
           <a:fontRef idx="minor">
-            <a:schemeClr val="tx1"/>
+            <a:schemeClr val="lt1"/>
           </a:fontRef>
         </p:style>
-      </p:cxnSp>
+        <p:txBody>
+          <a:bodyPr rtlCol="0" anchor="ctr"/>
+          <a:lstStyle/>
+          <a:p>
+            <a:pPr algn="ctr"/>
+          </a:p>
+        </p:txBody>
+      </p:sp>
       <p:sp>
         <p:nvSpPr>
           <p:cNvPr id="7" name="TextBox 6"/>
@@ -22210,41 +22336,50 @@
           </a:p>
         </p:txBody>
       </p:sp>
-      <p:cxnSp>
-        <p:nvCxnSpPr>
-          <p:cNvPr id="6" name="Connector 5"/>
-          <p:cNvCxnSpPr/>
-          <p:nvPr/>
-        </p:nvCxnSpPr>
-        <p:spPr>
-          <a:xfrm>
-            <a:off x="566928" y="1591056"/>
-            <a:ext cx="11058113" cy="0"/>
-          </a:xfrm>
-          <a:prstGeom prst="line">
-            <a:avLst/>
-          </a:prstGeom>
-          <a:ln w="12700">
-            <a:solidFill>
-              <a:srgbClr val="D9E0EA"/>
-            </a:solidFill>
+      <p:sp>
+        <p:nvSpPr>
+          <p:cNvPr id="6" name="Rectangle 5"/>
+          <p:cNvSpPr/>
+          <p:nvPr/>
+        </p:nvSpPr>
+        <p:spPr>
+          <a:xfrm>
+            <a:off x="566928" y="1584706"/>
+            <a:ext cx="11058113" cy="12700"/>
+          </a:xfrm>
+          <a:prstGeom prst="rect">
+            <a:avLst/>
+          </a:prstGeom>
+          <a:solidFill>
+            <a:srgbClr val="D9E0EA"/>
+          </a:solidFill>
+          <a:ln>
+            <a:noFill/>
           </a:ln>
+          <a:effectLst/>
         </p:spPr>
         <p:style>
-          <a:lnRef idx="2">
+          <a:lnRef idx="1">
             <a:schemeClr val="accent1"/>
           </a:lnRef>
-          <a:fillRef idx="0">
+          <a:fillRef idx="3">
             <a:schemeClr val="accent1"/>
           </a:fillRef>
-          <a:effectRef idx="1">
+          <a:effectRef idx="2">
             <a:schemeClr val="accent1"/>
           </a:effectRef>
           <a:fontRef idx="minor">
-            <a:schemeClr val="tx1"/>
+            <a:schemeClr val="lt1"/>
           </a:fontRef>
         </p:style>
-      </p:cxnSp>
+        <p:txBody>
+          <a:bodyPr rtlCol="0" anchor="ctr"/>
+          <a:lstStyle/>
+          <a:p>
+            <a:pPr algn="ctr"/>
+          </a:p>
+        </p:txBody>
+      </p:sp>
       <p:sp>
         <p:nvSpPr>
           <p:cNvPr id="7" name="TextBox 6"/>
@@ -23357,41 +23492,50 @@
           </a:p>
         </p:txBody>
       </p:sp>
-      <p:cxnSp>
-        <p:nvCxnSpPr>
-          <p:cNvPr id="6" name="Connector 5"/>
-          <p:cNvCxnSpPr/>
-          <p:nvPr/>
-        </p:nvCxnSpPr>
-        <p:spPr>
-          <a:xfrm>
-            <a:off x="566928" y="1591056"/>
-            <a:ext cx="11058113" cy="0"/>
-          </a:xfrm>
-          <a:prstGeom prst="line">
-            <a:avLst/>
-          </a:prstGeom>
-          <a:ln w="12700">
-            <a:solidFill>
-              <a:srgbClr val="D9E0EA"/>
-            </a:solidFill>
+      <p:sp>
+        <p:nvSpPr>
+          <p:cNvPr id="6" name="Rectangle 5"/>
+          <p:cNvSpPr/>
+          <p:nvPr/>
+        </p:nvSpPr>
+        <p:spPr>
+          <a:xfrm>
+            <a:off x="566928" y="1584706"/>
+            <a:ext cx="11058113" cy="12700"/>
+          </a:xfrm>
+          <a:prstGeom prst="rect">
+            <a:avLst/>
+          </a:prstGeom>
+          <a:solidFill>
+            <a:srgbClr val="D9E0EA"/>
+          </a:solidFill>
+          <a:ln>
+            <a:noFill/>
           </a:ln>
+          <a:effectLst/>
         </p:spPr>
         <p:style>
-          <a:lnRef idx="2">
+          <a:lnRef idx="1">
             <a:schemeClr val="accent1"/>
           </a:lnRef>
-          <a:fillRef idx="0">
+          <a:fillRef idx="3">
             <a:schemeClr val="accent1"/>
           </a:fillRef>
-          <a:effectRef idx="1">
+          <a:effectRef idx="2">
             <a:schemeClr val="accent1"/>
           </a:effectRef>
           <a:fontRef idx="minor">
-            <a:schemeClr val="tx1"/>
+            <a:schemeClr val="lt1"/>
           </a:fontRef>
         </p:style>
-      </p:cxnSp>
+        <p:txBody>
+          <a:bodyPr rtlCol="0" anchor="ctr"/>
+          <a:lstStyle/>
+          <a:p>
+            <a:pPr algn="ctr"/>
+          </a:p>
+        </p:txBody>
+      </p:sp>
       <p:sp>
         <p:nvSpPr>
           <p:cNvPr id="7" name="TextBox 6"/>
@@ -24984,41 +25128,50 @@
           </a:p>
         </p:txBody>
       </p:sp>
-      <p:cxnSp>
-        <p:nvCxnSpPr>
-          <p:cNvPr id="6" name="Connector 5"/>
-          <p:cNvCxnSpPr/>
-          <p:nvPr/>
-        </p:nvCxnSpPr>
-        <p:spPr>
-          <a:xfrm>
-            <a:off x="566928" y="1591056"/>
-            <a:ext cx="11058113" cy="0"/>
-          </a:xfrm>
-          <a:prstGeom prst="line">
-            <a:avLst/>
-          </a:prstGeom>
-          <a:ln w="12700">
-            <a:solidFill>
-              <a:srgbClr val="D9E0EA"/>
-            </a:solidFill>
+      <p:sp>
+        <p:nvSpPr>
+          <p:cNvPr id="6" name="Rectangle 5"/>
+          <p:cNvSpPr/>
+          <p:nvPr/>
+        </p:nvSpPr>
+        <p:spPr>
+          <a:xfrm>
+            <a:off x="566928" y="1584706"/>
+            <a:ext cx="11058113" cy="12700"/>
+          </a:xfrm>
+          <a:prstGeom prst="rect">
+            <a:avLst/>
+          </a:prstGeom>
+          <a:solidFill>
+            <a:srgbClr val="D9E0EA"/>
+          </a:solidFill>
+          <a:ln>
+            <a:noFill/>
           </a:ln>
+          <a:effectLst/>
         </p:spPr>
         <p:style>
-          <a:lnRef idx="2">
+          <a:lnRef idx="1">
             <a:schemeClr val="accent1"/>
           </a:lnRef>
-          <a:fillRef idx="0">
+          <a:fillRef idx="3">
             <a:schemeClr val="accent1"/>
           </a:fillRef>
-          <a:effectRef idx="1">
+          <a:effectRef idx="2">
             <a:schemeClr val="accent1"/>
           </a:effectRef>
           <a:fontRef idx="minor">
-            <a:schemeClr val="tx1"/>
+            <a:schemeClr val="lt1"/>
           </a:fontRef>
         </p:style>
-      </p:cxnSp>
+        <p:txBody>
+          <a:bodyPr rtlCol="0" anchor="ctr"/>
+          <a:lstStyle/>
+          <a:p>
+            <a:pPr algn="ctr"/>
+          </a:p>
+        </p:txBody>
+      </p:sp>
       <p:sp>
         <p:nvSpPr>
           <p:cNvPr id="7" name="TextBox 6"/>
@@ -26351,41 +26504,50 @@
           </a:p>
         </p:txBody>
       </p:sp>
-      <p:cxnSp>
-        <p:nvCxnSpPr>
-          <p:cNvPr id="6" name="Connector 5"/>
-          <p:cNvCxnSpPr/>
-          <p:nvPr/>
-        </p:nvCxnSpPr>
-        <p:spPr>
-          <a:xfrm>
-            <a:off x="566928" y="1591056"/>
-            <a:ext cx="11058113" cy="0"/>
-          </a:xfrm>
-          <a:prstGeom prst="line">
-            <a:avLst/>
-          </a:prstGeom>
-          <a:ln w="12700">
-            <a:solidFill>
-              <a:srgbClr val="D9E0EA"/>
-            </a:solidFill>
+      <p:sp>
+        <p:nvSpPr>
+          <p:cNvPr id="6" name="Rectangle 5"/>
+          <p:cNvSpPr/>
+          <p:nvPr/>
+        </p:nvSpPr>
+        <p:spPr>
+          <a:xfrm>
+            <a:off x="566928" y="1584706"/>
+            <a:ext cx="11058113" cy="12700"/>
+          </a:xfrm>
+          <a:prstGeom prst="rect">
+            <a:avLst/>
+          </a:prstGeom>
+          <a:solidFill>
+            <a:srgbClr val="D9E0EA"/>
+          </a:solidFill>
+          <a:ln>
+            <a:noFill/>
           </a:ln>
+          <a:effectLst/>
         </p:spPr>
         <p:style>
-          <a:lnRef idx="2">
+          <a:lnRef idx="1">
             <a:schemeClr val="accent1"/>
           </a:lnRef>
-          <a:fillRef idx="0">
+          <a:fillRef idx="3">
             <a:schemeClr val="accent1"/>
           </a:fillRef>
-          <a:effectRef idx="1">
+          <a:effectRef idx="2">
             <a:schemeClr val="accent1"/>
           </a:effectRef>
           <a:fontRef idx="minor">
-            <a:schemeClr val="tx1"/>
+            <a:schemeClr val="lt1"/>
           </a:fontRef>
         </p:style>
-      </p:cxnSp>
+        <p:txBody>
+          <a:bodyPr rtlCol="0" anchor="ctr"/>
+          <a:lstStyle/>
+          <a:p>
+            <a:pPr algn="ctr"/>
+          </a:p>
+        </p:txBody>
+      </p:sp>
       <p:sp>
         <p:nvSpPr>
           <p:cNvPr id="7" name="TextBox 6"/>

</xml_diff>